<commit_message>
Génère aussi le PowerPoint « IA & communication » (même générateur)
La formation IA réutilise le modèle CommSeminaire/CommSlide → on généralise le
générateur (fonction generate(seminaire, outPath)) et on produit les DEUX decks
d'un coup. Le PPTX IA, comme celui de Communication pastorale, est désormais une
mise en page propre (régions bornées, fit:shrink, vrai tableau) au lieu de
l'ancien deck repacké.

- scripts/build-pptx-comm-pastorale.mts : factorisé en generate() ; main() rend
  communication-pastorale (14 slides) + ia-communication (13 slides).
- npm run build:pptx (renommé) construit les deux.
- Audit géométrique : 0 objet hors cadre sur les deux. IA 0,30 Mo, Comm 0,40 Mo.

Co-Authored-By: Claude Opus 4.8 <noreply@anthropic.com>
</commit_message>
<xml_diff>
--- a/public/seminaires/communication-pastorale/support.pptx
+++ b/public/seminaires/communication-pastorale/support.pptx
@@ -2252,16 +2252,18 @@
         <p:spPr>
           <a:xfrm>
             <a:off x="768096" y="4443984"/>
-            <a:ext cx="640080" cy="457200"/>
-          </a:xfrm>
-          <a:prstGeom prst="rect">
-            <a:avLst/>
-          </a:prstGeom>
-          <a:noFill/>
-          <a:ln/>
-        </p:spPr>
-        <p:txBody>
-          <a:bodyPr wrap="square" rtlCol="0" anchor="t"/>
+            <a:ext cx="3100730" cy="457200"/>
+          </a:xfrm>
+          <a:prstGeom prst="rect">
+            <a:avLst/>
+          </a:prstGeom>
+          <a:noFill/>
+          <a:ln/>
+        </p:spPr>
+        <p:txBody>
+          <a:bodyPr wrap="square" rtlCol="0" anchor="t">
+            <a:normAutofit/>
+          </a:bodyPr>
           <a:lstStyle/>
           <a:p>
             <a:pPr algn="l" indent="0" marL="0">
@@ -2400,16 +2402,18 @@
         <p:spPr>
           <a:xfrm>
             <a:off x="4545482" y="4443984"/>
-            <a:ext cx="640080" cy="457200"/>
-          </a:xfrm>
-          <a:prstGeom prst="rect">
-            <a:avLst/>
-          </a:prstGeom>
-          <a:noFill/>
-          <a:ln/>
-        </p:spPr>
-        <p:txBody>
-          <a:bodyPr wrap="square" rtlCol="0" anchor="t"/>
+            <a:ext cx="3100730" cy="457200"/>
+          </a:xfrm>
+          <a:prstGeom prst="rect">
+            <a:avLst/>
+          </a:prstGeom>
+          <a:noFill/>
+          <a:ln/>
+        </p:spPr>
+        <p:txBody>
+          <a:bodyPr wrap="square" rtlCol="0" anchor="t">
+            <a:normAutofit/>
+          </a:bodyPr>
           <a:lstStyle/>
           <a:p>
             <a:pPr algn="l" indent="0" marL="0">
@@ -2548,16 +2552,18 @@
         <p:spPr>
           <a:xfrm>
             <a:off x="8322869" y="4443984"/>
-            <a:ext cx="640080" cy="457200"/>
-          </a:xfrm>
-          <a:prstGeom prst="rect">
-            <a:avLst/>
-          </a:prstGeom>
-          <a:noFill/>
-          <a:ln/>
-        </p:spPr>
-        <p:txBody>
-          <a:bodyPr wrap="square" rtlCol="0" anchor="t"/>
+            <a:ext cx="3100730" cy="457200"/>
+          </a:xfrm>
+          <a:prstGeom prst="rect">
+            <a:avLst/>
+          </a:prstGeom>
+          <a:noFill/>
+          <a:ln/>
+        </p:spPr>
+        <p:txBody>
+          <a:bodyPr wrap="square" rtlCol="0" anchor="t">
+            <a:normAutofit/>
+          </a:bodyPr>
           <a:lstStyle/>
           <a:p>
             <a:pPr algn="l" indent="0" marL="0">

</xml_diff>